<commit_message>
feat(de): B abgeschlossen – deutsche Kategorien zuerst, englische gekennzeichnet, Prüfer kennt deutsche Einträge; Handbuch, Präsentation, Videos auf deutsche Inhalte umgestellt
Co-Authored-By: Claude Sonnet 5.5 <noreply@anthropic.com>
</commit_message>
<xml_diff>
--- a/de/praesentation/NOMAD-Praesentation.pptx
+++ b/de/praesentation/NOMAD-Praesentation.pptx
@@ -806,7 +806,7 @@
           <a:lstStyle/>
           <a:p>
             <a:r>
-              <a:t>Jeder Themenbereich hat drei Stufen. Essential ist das Wichtigste und klein. Alle Bereiche zusammen sind etwa 6 Gigabyte. Standard sind etwa 36 Gigabyte, Comprehensive etwa 89 Gigabyte. Wikipedia kommt je nach Wunsch dazu, von 0,3 bis 121 Gigabyte.</a:t>
+              <a:t>Jeder Themenbereich hat drei Stufen: Basis, Standard und Umfassend. Basis ist das Wichtigste und klein. Alle deutschen Bereiche zusammen sind in der Basisstufe nur etwa ein halbes Gigabyte, in Standard etwa 6,7 und in Umfassend etwa 23 Gigabyte. Die englischen Bereiche sind größer, bis zu 89 Gigabyte. Die deutsche Wikipedia kommt je nach Wunsch dazu, von 0,14 bis 51 Gigabyte.</a:t>
             </a:r>
           </a:p>
         </p:txBody>
@@ -1576,7 +1576,7 @@
           <a:lstStyle/>
           <a:p>
             <a:r>
-              <a:t>Zur Ehrlichkeit gehören die Grenzen. Die Inhalte sind überwiegend englisch. Die Länderliste und die Beschriftung der Karten sind englisch. Es gibt keine Unterstützung für Mac und ARM-Rechner. Das Anfangspasswort der USB-SSD ist für alle gleich, bitte ändern Sie es. Und bestimmte Nachschlagewerke, die als PDF vorliegen, kann die KI nicht durchsuchen.</a:t>
+              <a:t>Zur Ehrlichkeit gehören die Grenzen. Für Überleben, Vorsorge und die medizinischen Nachschlagewerke gibt es bisher nur englische Bücher. Die Beschriftung der Karten ist englisch. Es gibt keine Unterstützung für Mac und ARM-Rechner. Das Anfangspasswort der USB-SSD ist für alle gleich, bitte ändern Sie es. Und bestimmte Nachschlagewerke, die als PDF vorliegen, kann die KI nicht durchsuchen.</a:t>
             </a:r>
           </a:p>
         </p:txBody>
@@ -2206,7 +2206,7 @@
           <a:lstStyle/>
           <a:p>
             <a:r>
-              <a:t>Was steckt in NOMAD? Wikipedia und viele Nachschlagewerke, zum Beispiel zu Medizin und Überleben. Karten, bei denen Sie ganze Länder wählen können, auch Deutschland. Lernmaterial. Ein Chat mit einer KI, die auf Ihrem Rechner läuft. Und Ihre eigenen Dokumente.</a:t>
+              <a:t>Was steckt in NOMAD? Die deutsche und die englische Wikipedia und viele Nachschlagewerke, zum Beispiel zu Medizin, Kochen und Reparieren. Karten, bei denen Sie ganze Länder wählen können, auch Deutschland. Lernmaterial. Ein Chat mit einer KI, die auf Ihrem Rechner läuft. Und Ihre eigenen Dokumente.</a:t>
             </a:r>
           </a:p>
         </p:txBody>
@@ -6369,7 +6369,7 @@
                 </a:solidFill>
                 <a:latin typeface="Arial"/>
               </a:rPr>
-              <a:t>Essential ≈ 6 GB · Standard ≈ 36 GB · Comprehensive ≈ 89 GB (alle Bereiche zusammen)</a:t>
+              <a:t>Deutsch: Basis ≈ 0,5 GB · Standard ≈ 6,7 GB · Umfassend ≈ 23 GB  (Englisch: 6 · 36 · 89 GB)</a:t>
             </a:r>
           </a:p>
         </p:txBody>
@@ -9984,7 +9984,7 @@
                 </a:solidFill>
                 <a:latin typeface="Arial"/>
               </a:rPr>
-              <a:t>•  Die Inhalte sind überwiegend </a:t>
+              <a:t>•  Überleben, Vorsorge und medizinische Nachschlagewerke: bisher nur </a:t>
             </a:r>
             <a:r>
               <a:rPr sz="2400" b="1">
@@ -10009,7 +10009,7 @@
                 </a:solidFill>
                 <a:latin typeface="Arial"/>
               </a:rPr>
-              <a:t>•  Länderliste und Kartenbeschriftung sind englisch</a:t>
+              <a:t>•  Die Kartenbeschriftung ist englisch</a:t>
             </a:r>
           </a:p>
           <a:p>
@@ -12861,7 +12861,7 @@
                 </a:solidFill>
                 <a:latin typeface="Arial"/>
               </a:rPr>
-              <a:t> und Nachschlagewerke</a:t>
+              <a:t> (deutsch und englisch) und Nachschlagewerke</a:t>
             </a:r>
           </a:p>
           <a:p>

</xml_diff>